<commit_message>
docs: align submission artifacts with authoritative protocol, temporal splits, B2 alpha, and B8 architecture
</commit_message>
<xml_diff>
--- a/submission/Final_Project_Presentation.pptx
+++ b/submission/Final_Project_Presentation.pptx
@@ -3338,7 +3338,7 @@
             </a:r>
             <a:br/>
             <a:r>
-              <a:t>• Controls: 6-Day Purge Buffers (Zero Leakage) | Train-Only Normalization | Strict Chronological 2020 Partition</a:t>
+              <a:t>• Controls: 6-Day Purge Buffers (Zero Leakage) | Train-Only Normalization | Strict Chronological 2020 Partition (Test: Days 313–365)</a:t>
             </a:r>
           </a:p>
         </p:txBody>
@@ -4244,12 +4244,12 @@
               </a:defRPr>
             </a:pPr>
             <a:r>
-              <a:t>• B8 Spatiotemporal Embedding achieves 0.9800 °C overall test RMSE (22.11% gain vs climatology).</a:t>
-            </a:r>
-            <a:br/>
-            <a:br/>
-            <a:r>
-              <a:t>• Spatial context + causal temporal memory is strictly necessary: uncoupled architectures fail to beat tabular baselines.</a:t>
+              <a:t>• B8 Spatiotemporal Embedding achieves 0.9800 °C overall column-averaged test RMSE (22.11% gain vs climatology).</a:t>
+            </a:r>
+            <a:br/>
+            <a:br/>
+            <a:r>
+              <a:t>• Spatial context + causal temporal memory captures predictive relationships: uncoupled architectures fail to beat tabular baselines.</a:t>
             </a:r>
             <a:br/>
             <a:br/>
@@ -4591,7 +4591,7 @@
             <a:br/>
             <a:br/>
             <a:r>
-              <a:t>• Average spatial separation between floats is 300 km: insufficient for mesoscale eddy dynamics (&lt;100 km).</a:t>
+              <a:t>• Average spatial separation between floats is ~300 km: insufficient for mesoscale eddy dynamics (&lt;100 km).</a:t>
             </a:r>
             <a:br/>
             <a:br/>
@@ -4689,7 +4689,7 @@
               </a:defRPr>
             </a:pPr>
             <a:r>
-              <a:t>• Surface variables contain indirect hydrodynamic signatures of subsurface dynamics (SSH geostrophy, SST heating, SSS buoyancy, Ekman pumping).</a:t>
+              <a:t>• Surface variables contain hydrodynamic signatures of subsurface dynamics (SSH geostrophy, SST heating, SSS buoyancy, Ekman pumping).</a:t>
             </a:r>
             <a:br/>
             <a:br/>
@@ -4699,7 +4699,7 @@
             <a:br/>
             <a:br/>
             <a:r>
-              <a:t>• Provides daily, high-resolution (0.25°), synoptic 3D temperature fields across the full basin.</a:t>
+              <a:t>• Provides daily, high-resolution (0.25°), synoptic 3D temperature fields across the full basin against GLORYS reanalysis.</a:t>
             </a:r>
           </a:p>
         </p:txBody>
@@ -4947,7 +4947,7 @@
             </a:r>
             <a:br/>
             <a:r>
-              <a:t>• Target Reference: CMEMS GLORYS12V1 (1/12° daily reanalysis)</a:t>
+              <a:t>• Target Reference: CMEMS GLORYS12V1 (1/12° daily reanalysis, reference state)</a:t>
             </a:r>
           </a:p>
         </p:txBody>
@@ -6030,11 +6030,11 @@
               </a:defRPr>
             </a:pPr>
             <a:r>
-              <a:t>TRAIN SET (Days 1–245: Jan 1 – Sep 1)    |   PURGE 1 (Days 246–251)   |   VAL SET (Days 252–304: Sep 8 – Oct 30)   |   PURGE 2 (Days 305–310)   |   TEST SET (Days 311–366: Nov 6 – Dec 31)</a:t>
-            </a:r>
-            <a:br/>
-            <a:r>
-              <a:t>  245 Days (~67% of calendar)                   6-Day Purge Buffer                 53 Days (~14.5%)                         6-Day Purge Buffer                 56 Days (~15.3%)</a:t>
+              <a:t>TRAIN SET (Days 0–252: Jan 1 – Sep 9)   |   PURGE 1 (Days 253–258)   |   VAL SET (Days 259–306: Sep 16 – Nov 2)   |   PURGE 2 (Days 307–312)   |   TEST SET (Days 313–365: Nov 9 – Dec 31)</a:t>
+            </a:r>
+            <a:br/>
+            <a:r>
+              <a:t>  253 Days (~69.1% of calendar)              6-Day Purge Buffer                48 Days (~13.1%)                         6-Day Purge Buffer                 53 Days (~14.5%)</a:t>
             </a:r>
           </a:p>
           <a:p>
@@ -6139,7 +6139,7 @@
               </a:defRPr>
             </a:pPr>
             <a:r>
-              <a:t>• Mean &amp; standard deviation fitted strictly on training days (1–245).</a:t>
+              <a:t>• Mean &amp; standard deviation fitted strictly on training days (0–252).</a:t>
             </a:r>
             <a:br/>
             <a:r>
@@ -6748,7 +6748,7 @@
                         </a:defRPr>
                       </a:pPr>
                       <a:r>
-                        <a:t>B0: 1-Day Lag Persistence</a:t>
+                        <a:t>B0: Day-0 Persistence</a:t>
                       </a:r>
                       <a:br/>
                       <a:r>
@@ -6881,7 +6881,7 @@
                         </a:defRPr>
                       </a:pPr>
                       <a:r>
-                        <a:t>B2: Ridge Regression</a:t>
+                        <a:t>B2: Ridge (alpha=100,000)</a:t>
                       </a:r>
                       <a:br/>
                       <a:r>
@@ -6958,7 +6958,7 @@
                         </a:defRPr>
                       </a:pPr>
                       <a:r>
-                        <a:t>All tabular ML models beat B1 (~1.028–1.045 °C). Surface coupling is strong and real.</a:t>
+                        <a:t>All tabular ML models beat B1 (~1.028–1.045 °C). Surface coupling provides strong predictive signals.</a:t>
                       </a:r>
                     </a:p>
                   </a:txBody>
@@ -7465,7 +7465,7 @@
             <a:br/>
             <a:br/>
             <a:r>
-              <a:t>• AdaptiveAvgPool2D((1, 1))</a:t>
+              <a:t>• AdaptiveAvgPool2D((1, 1)) + Flatten</a:t>
             </a:r>
             <a:br/>
             <a:br/>
@@ -7568,17 +7568,17 @@
             <a:br/>
             <a:br/>
             <a:r>
-              <a:t>• Recurrent Core: 2-layer Gated Recurrent Unit (hidden_dim = 128, batch_first=True).</a:t>
-            </a:r>
-            <a:br/>
-            <a:br/>
-            <a:r>
-              <a:t>• Gating captures baroclinic wave propagation and mixed-layer lag dynamics.</a:t>
-            </a:r>
-            <a:br/>
-            <a:br/>
-            <a:r>
-              <a:t>• Latent Representation: Final hidden state h_5 ∈ ℝ^{128} serves as the compressed Ocean Embedding.</a:t>
+              <a:t>• Recurrent Core: 2-layer Gated Recurrent Unit (input_size=64, hidden_size=128, batch_first=True).</a:t>
+            </a:r>
+            <a:br/>
+            <a:br/>
+            <a:r>
+              <a:t>• Latent Bottleneck: LayerNorm(128) applied to terminal hidden state h_5 ∈ ℝ^{128}.</a:t>
+            </a:r>
+            <a:br/>
+            <a:br/>
+            <a:r>
+              <a:t>• Produces 128-dimensional compressed ocean latent embedding.</a:t>
             </a:r>
           </a:p>
         </p:txBody>
@@ -7676,34 +7676,27 @@
             <a:br/>
             <a:br/>
             <a:r>
-              <a:t>• Dense Layer 1: Linear(128 → 128)</a:t>
-            </a:r>
-            <a:br/>
-            <a:r>
-              <a:t>  + BatchNorm1D + ReLU + Dropout(0.1)</a:t>
-            </a:r>
-            <a:br/>
-            <a:br/>
-            <a:r>
-              <a:t>• Dense Layer 2: Linear(128 → 64)</a:t>
-            </a:r>
-            <a:br/>
-            <a:r>
-              <a:t>  + BatchNorm1D + ReLU</a:t>
-            </a:r>
-            <a:br/>
-            <a:br/>
-            <a:r>
-              <a:t>• Output Projection: Linear(64 → 15)</a:t>
-            </a:r>
-            <a:br/>
-            <a:r>
-              <a:t>  yielding predicted temperature profile across all 15 depths.</a:t>
+              <a:t>• Projection Layer 1: Linear(128 → 64) + ReLU</a:t>
+            </a:r>
+            <a:br/>
+            <a:br/>
+            <a:r>
+              <a:t>• Projection Layer 2: Linear(64 → 15)</a:t>
+            </a:r>
+            <a:br/>
+            <a:br/>
+            <a:r>
+              <a:t>• Output: Predicted temperature profile across all 15 canonical depths.</a:t>
             </a:r>
             <a:br/>
             <a:br/>
             <a:r>
               <a:t>• Total Model Parameters: 203,791 (0.81 MB memory footprint).</a:t>
+            </a:r>
+            <a:br/>
+            <a:br/>
+            <a:r>
+              <a:t>• Lightweight architecture suitable for efficient inference.</a:t>
             </a:r>
           </a:p>
         </p:txBody>
@@ -7914,7 +7907,7 @@
               </a:defRPr>
             </a:pPr>
             <a:r>
-              <a:t>Independent Test Partition Evaluation (Days 311–366, Full Basin)</a:t>
+              <a:t>Independent Test Partition Evaluation (Days 313–365, Full Basin)</a:t>
             </a:r>
           </a:p>
         </p:txBody>
@@ -8122,7 +8115,7 @@
                         </a:defRPr>
                       </a:pPr>
                       <a:r>
-                        <a:t>1-Day Lag Persistence</a:t>
+                        <a:t>Day-0 Persistence</a:t>
                       </a:r>
                     </a:p>
                   </a:txBody>
@@ -8542,7 +8535,7 @@
                         </a:defRPr>
                       </a:pPr>
                       <a:r>
-                        <a:t>Ridge Linear Regression (alpha=1.0)</a:t>
+                        <a:t>Ridge Regression (alpha=100,000)</a:t>
                       </a:r>
                     </a:p>
                   </a:txBody>
@@ -10973,7 +10966,7 @@
             </a:r>
             <a:br/>
             <a:r>
-              <a:t>   Mesopelagic waters have low ambient thermal variance (σ &lt; 0.8 °C). The network accurately captures this stable baseline.</a:t>
+              <a:t>   Mesopelagic waters have low ambient thermal variance (σ &lt; 0.8 °C). The network captures this stable baseline.</a:t>
             </a:r>
             <a:br/>
             <a:br/>
@@ -11317,7 +11310,7 @@
               </a:defRPr>
             </a:pPr>
             <a:r>
-              <a:t>• Late Fall (Nov 6 – Nov 30): 1.0059 °C</a:t>
+              <a:t>• Late Fall (Nov 09 – Nov 30): 1.0059 °C</a:t>
             </a:r>
             <a:br/>
             <a:r>
@@ -11326,7 +11319,7 @@
             <a:br/>
             <a:br/>
             <a:r>
-              <a:t>• Early Winter (Dec 1 – Dec 31): 0.9060 °C</a:t>
+              <a:t>• Early Winter (Dec 01 – Dec 31): 0.9060 °C</a:t>
             </a:r>
             <a:br/>
             <a:r>
@@ -11339,11 +11332,11 @@
             </a:r>
             <a:br/>
             <a:r>
-              <a:t>  - SW Monsoon and Pre-Monsoon occur entirely within the Training split (Days 1–245).</a:t>
-            </a:r>
-            <a:br/>
-            <a:r>
-              <a:t>  - In adherence to protocol, only Late Fall and Early Winter exist in the certified Test partition.</a:t>
+              <a:t>  - SW Monsoon and Pre-Monsoon occur entirely within the Training split (Days 0–252).</a:t>
+            </a:r>
+            <a:br/>
+            <a:r>
+              <a:t>  - In adherence to protocol, only Late Fall and Early Winter exist in the certified Test partition (Days 313–365).</a:t>
             </a:r>
           </a:p>
         </p:txBody>

</xml_diff>